<commit_message>
Update PowerPoint golden fixtures for font changes
Co-authored-by: Copilot <223556219+Copilot@users.noreply.github.com>
</commit_message>
<xml_diff>
--- a/.github/extensions/markdstage/test/fixtures/pptx-editable.golden.pptx
+++ b/.github/extensions/markdstage/test/fixtures/pptx-editable.golden.pptx
@@ -17,89 +17,7 @@
 </p:presentation>
 </file>
 
-<file path=ppt/notesMasters/notesMaster1.xml><?xml version="1.0" encoding="utf-8"?>
-<p:notesMaster xmlns:a="http://schemas.openxmlformats.org/drawingml/2006/main" xmlns:r="http://schemas.openxmlformats.org/officeDocument/2006/relationships" xmlns:p="http://schemas.openxmlformats.org/presentationml/2006/main">
-  <p:cSld name="Notes Master">
-    <p:spTree>
-      <p:nvGrpSpPr>
-        <p:cNvPr id="1" name=""/>
-        <p:cNvGrpSpPr/>
-        <p:nvPr/>
-      </p:nvGrpSpPr>
-      <p:grpSpPr>
-        <a:xfrm>
-          <a:off x="0" y="0"/>
-          <a:ext cx="0" cy="0"/>
-          <a:chOff x="0" y="0"/>
-          <a:chExt cx="0" cy="0"/>
-        </a:xfrm>
-      </p:grpSpPr>
-      <p:sp>
-        <p:nvSpPr>
-          <p:cNvPr id="2" name="Slide Image Placeholder 1"/>
-          <p:cNvSpPr txBox="1"/>
-          <p:nvPr>
-            <p:ph type="sldImg" idx="1"/>
-          </p:nvPr>
-        </p:nvSpPr>
-        <p:spPr>
-          <a:xfrm>
-            <a:off x="1143000" y="685800"/>
-            <a:ext cx="4572000" cy="3429000"/>
-          </a:xfrm>
-          <a:prstGeom prst="rect">
-            <a:avLst/>
-          </a:prstGeom>
-          <a:noFill/>
-          <a:ln>
-            <a:noFill/>
-          </a:ln>
-        </p:spPr>
-        <p:txBody>
-          <a:bodyPr/>
-          <a:lstStyle/>
-          <a:p/>
-        </p:txBody>
-      </p:sp>
-      <p:sp>
-        <p:nvSpPr>
-          <p:cNvPr id="3" name="Notes Placeholder 2"/>
-          <p:cNvSpPr txBox="1"/>
-          <p:nvPr>
-            <p:ph type="body" idx="2"/>
-          </p:nvPr>
-        </p:nvSpPr>
-        <p:spPr>
-          <a:xfrm>
-            <a:off x="685800" y="4343400"/>
-            <a:ext cx="5486400" cy="4114800"/>
-          </a:xfrm>
-          <a:prstGeom prst="rect">
-            <a:avLst/>
-          </a:prstGeom>
-          <a:noFill/>
-          <a:ln>
-            <a:noFill/>
-          </a:ln>
-        </p:spPr>
-        <p:txBody>
-          <a:bodyPr/>
-          <a:lstStyle/>
-          <a:p/>
-        </p:txBody>
-      </p:sp>
-    </p:spTree>
-  </p:cSld>
-  <p:clrMap accent1="accent1" accent2="accent2" accent3="accent3" accent4="accent4" accent5="accent5" accent6="accent6" bg1="lt1" bg2="lt2" folHlink="folHlink" hlink="hlink" tx1="dk1" tx2="dk2"/>
-  <p:notesStyle>
-    <a:lvl1pPr marL="0" algn="l">
-      <a:defRPr sz="1200">
-        <a:latin typeface="Aptos"/>
-        <a:ea typeface="Yu Gothic"/>
-      </a:defRPr>
-    </a:lvl1pPr>
-  </p:notesStyle>
-</p:notesMaster>
+<file path=ppt/notesMasters/notesMaster1.xml><?xml version="1.0" encoding="UTF-8" standalone="yes"?><p:notesMaster xmlns:a="http://schemas.openxmlformats.org/drawingml/2006/main" xmlns:r="http://schemas.openxmlformats.org/officeDocument/2006/relationships" xmlns:p="http://schemas.openxmlformats.org/presentationml/2006/main"><p:cSld name="Notes Master"><p:spTree><p:nvGrpSpPr><p:cNvPr id="1" name=""/><p:cNvGrpSpPr/><p:nvPr/></p:nvGrpSpPr><p:grpSpPr><a:xfrm><a:off x="0" y="0"/><a:ext cx="0" cy="0"/><a:chOff x="0" y="0"/><a:chExt cx="0" cy="0"/></a:xfrm></p:grpSpPr><p:sp><p:nvSpPr><p:cNvPr id="2" name="Slide Image Placeholder 1"/><p:cNvSpPr txBox="1"/><p:nvPr><p:ph type="sldImg" idx="1"/></p:nvPr></p:nvSpPr><p:spPr><a:xfrm><a:off x="1143000" y="685800"/><a:ext cx="4572000" cy="3429000"/></a:xfrm><a:prstGeom prst="rect"><a:avLst/></a:prstGeom><a:noFill/><a:ln><a:noFill/></a:ln></p:spPr><p:txBody><a:bodyPr/><a:lstStyle/><a:p/></p:txBody></p:sp><p:sp><p:nvSpPr><p:cNvPr id="3" name="Notes Placeholder 2"/><p:cNvSpPr txBox="1"/><p:nvPr><p:ph type="body" idx="2"/></p:nvPr></p:nvSpPr><p:spPr><a:xfrm><a:off x="685800" y="4343400"/><a:ext cx="5486400" cy="4114800"/></a:xfrm><a:prstGeom prst="rect"><a:avLst/></a:prstGeom><a:noFill/><a:ln><a:noFill/></a:ln></p:spPr><p:txBody><a:bodyPr/><a:lstStyle/><a:p/></p:txBody></p:sp></p:spTree></p:cSld><p:clrMap accent1="accent1" accent2="accent2" accent3="accent3" accent4="accent4" accent5="accent5" accent6="accent6" bg1="lt1" bg2="lt2" folHlink="folHlink" hlink="hlink" tx1="dk1" tx2="dk2"/><p:notesStyle><a:lvl1pPr marL="0" algn="l"><a:defRPr sz="1200"><a:latin typeface="Segoe UI"/><a:ea typeface="Yu Gothic UI"/></a:defRPr></a:lvl1pPr></p:notesMaster>
 </file>
 
 <file path=ppt/notesSlides/notesSlide1.xml><?xml version="1.0" encoding="utf-8"?>
@@ -173,28 +91,28 @@
           <a:p>
             <a:r>
               <a:rPr lang="en-US" dirty="0">
-                <a:ea typeface="Yu Gothic"/>
+                <a:ea typeface="Yu Gothic UI"/>
               </a:rPr>
               <a:t>発表者ノート &amp; &lt;詳細&gt;.</a:t>
             </a:r>
             <a:endParaRPr lang="en-US">
-              <a:ea typeface="Yu Gothic"/>
+              <a:ea typeface="Yu Gothic UI"/>
             </a:endParaRPr>
           </a:p>
           <a:p>
             <a:endParaRPr lang="en-US">
-              <a:ea typeface="Yu Gothic"/>
+              <a:ea typeface="Yu Gothic UI"/>
             </a:endParaRPr>
           </a:p>
           <a:p>
             <a:r>
               <a:rPr lang="en-US" dirty="0">
-                <a:ea typeface="Yu Gothic"/>
+                <a:ea typeface="Yu Gothic UI"/>
               </a:rPr>
               <a:t xml:space="preserve">  Кириллица — العربية 🧪</a:t>
             </a:r>
             <a:endParaRPr lang="en-US">
-              <a:ea typeface="Yu Gothic"/>
+              <a:ea typeface="Yu Gothic UI"/>
             </a:endParaRPr>
           </a:p>
         </p:txBody>
@@ -336,13 +254,13 @@
                   <a:srgbClr val="0C2238"/>
                 </a:solidFill>
                 <a:latin typeface="Yu Gothic"/>
-                <a:ea typeface="Yu Gothic"/>
+                <a:ea typeface="Yu Gothic UI"/>
                 <a:hlinkClick r:id="rId3"/>
               </a:rPr>
               <a:t>日本語 &amp; &lt;編集&gt; — Ελληνικά 🚀</a:t>
             </a:r>
             <a:endParaRPr lang="en-US" noProof="1">
-              <a:ea typeface="Yu Gothic"/>
+              <a:ea typeface="Yu Gothic UI"/>
             </a:endParaRPr>
           </a:p>
         </p:txBody>
@@ -377,12 +295,12 @@
                           <a:solidFill>
                             <a:srgbClr val="000000"/>
                           </a:solidFill>
-                          <a:ea typeface="Yu Gothic"/>
+                          <a:ea typeface="Yu Gothic UI"/>
                         </a:rPr>
                         <a:t>項目</a:t>
                       </a:r>
                       <a:endParaRPr lang="en-US" noProof="1">
-                        <a:ea typeface="Yu Gothic"/>
+                        <a:ea typeface="Yu Gothic UI"/>
                       </a:endParaRPr>
                     </a:p>
                   </a:txBody>
@@ -423,12 +341,12 @@
                           <a:solidFill>
                             <a:srgbClr val="000000"/>
                           </a:solidFill>
-                          <a:ea typeface="Yu Gothic"/>
+                          <a:ea typeface="Yu Gothic UI"/>
                         </a:rPr>
                         <a:t>値</a:t>
                       </a:r>
                       <a:endParaRPr lang="en-US" noProof="1">
-                        <a:ea typeface="Yu Gothic"/>
+                        <a:ea typeface="Yu Gothic UI"/>
                       </a:endParaRPr>
                     </a:p>
                   </a:txBody>
@@ -469,12 +387,12 @@
                           <a:solidFill>
                             <a:srgbClr val="000000"/>
                           </a:solidFill>
-                          <a:ea typeface="Yu Gothic"/>
+                          <a:ea typeface="Yu Gothic UI"/>
                         </a:rPr>
                         <a:t>Δ</a:t>
                       </a:r>
                       <a:endParaRPr lang="en-US" noProof="1">
-                        <a:ea typeface="Yu Gothic"/>
+                        <a:ea typeface="Yu Gothic UI"/>
                       </a:endParaRPr>
                     </a:p>
                   </a:txBody>
@@ -515,12 +433,12 @@
                           <a:solidFill>
                             <a:srgbClr val="000000"/>
                           </a:solidFill>
-                          <a:ea typeface="Yu Gothic"/>
+                          <a:ea typeface="Yu Gothic UI"/>
                         </a:rPr>
                         <a:t>42 &amp; &lt;43&gt;</a:t>
                       </a:r>
                       <a:endParaRPr lang="en-US" noProof="1">
-                        <a:ea typeface="Yu Gothic"/>
+                        <a:ea typeface="Yu Gothic UI"/>
                       </a:endParaRPr>
                     </a:p>
                   </a:txBody>
@@ -616,12 +534,12 @@
                 <a:solidFill>
                   <a:srgbClr val="000000"/>
                 </a:solidFill>
-                <a:ea typeface="Yu Gothic"/>
+                <a:ea typeface="Yu Gothic UI"/>
               </a:rPr>
               <a:t>編集可能</a:t>
             </a:r>
             <a:endParaRPr lang="en-US" noProof="1">
-              <a:ea typeface="Yu Gothic"/>
+              <a:ea typeface="Yu Gothic UI"/>
             </a:endParaRPr>
           </a:p>
         </p:txBody>
@@ -700,12 +618,12 @@
                 <a:solidFill>
                   <a:srgbClr val="000000"/>
                 </a:solidFill>
-                <a:ea typeface="Yu Gothic"/>
+                <a:ea typeface="Yu Gothic UI"/>
               </a:rPr>
               <a:t>流れ</a:t>
             </a:r>
             <a:endParaRPr lang="en-US" noProof="1">
-              <a:ea typeface="Yu Gothic"/>
+              <a:ea typeface="Yu Gothic UI"/>
             </a:endParaRPr>
           </a:p>
         </p:txBody>
@@ -786,16 +704,16 @@
     </a:clrScheme>
     <a:fontScheme name="MarkdStage dark">
       <a:majorFont>
-        <a:latin typeface="Aptos Display"/>
-        <a:ea typeface="Yu Gothic"/>
+        <a:latin typeface="Segoe UI"/>
+        <a:ea typeface="Yu Gothic UI"/>
         <a:cs typeface=""/>
-        <a:font script="Jpan" typeface="Yu Gothic"/>
+        <a:font script="Jpan" typeface="Yu Gothic UI"/>
       </a:majorFont>
       <a:minorFont>
-        <a:latin typeface="Aptos"/>
-        <a:ea typeface="Yu Gothic"/>
+        <a:latin typeface="Segoe UI"/>
+        <a:ea typeface="Yu Gothic UI"/>
         <a:cs typeface=""/>
-        <a:font script="Jpan" typeface="Yu Gothic"/>
+        <a:font script="Jpan" typeface="Yu Gothic UI"/>
       </a:minorFont>
     </a:fontScheme>
     <a:fmtScheme name="MarkdStage dark">
@@ -897,16 +815,16 @@
     </a:clrScheme>
     <a:fontScheme name="MarkdStage Notes">
       <a:majorFont>
-        <a:latin typeface="Aptos Display"/>
-        <a:ea typeface="Yu Gothic"/>
+        <a:latin typeface="Segoe UI"/>
+        <a:ea typeface="Yu Gothic UI"/>
         <a:cs typeface=""/>
-        <a:font script="Jpan" typeface="Yu Gothic"/>
+        <a:font script="Jpan" typeface="Yu Gothic UI"/>
       </a:majorFont>
       <a:minorFont>
-        <a:latin typeface="Aptos"/>
-        <a:ea typeface="Yu Gothic"/>
+        <a:latin typeface="Segoe UI"/>
+        <a:ea typeface="Yu Gothic UI"/>
         <a:cs typeface=""/>
-        <a:font script="Jpan" typeface="Yu Gothic"/>
+        <a:font script="Jpan" typeface="Yu Gothic UI"/>
       </a:minorFont>
     </a:fontScheme>
     <a:fmtScheme name="MarkdStage Notes">

</xml_diff>

<commit_message>
Standardize font fallback order across exports (#210)
* Use Yu Gothic UI for PowerPoint Japanese text

Co-authored-by: Copilot App <223556219+Copilot@users.noreply.github.com>

* Standardize font fallback order across exports

Co-authored-by: Copilot App <223556219+Copilot@users.noreply.github.com>

* Update PowerPoint golden fixtures for font changes

Co-authored-by: Copilot <223556219+Copilot@users.noreply.github.com>

* Preserve custom font overrides in fallback CSS

Co-authored-by: Copilot <223556219+Copilot@users.noreply.github.com>

---------

Co-authored-by: Kazuki Ota <117221407+kaota_microsoft@users.noreply.github.com>
Co-authored-by: Copilot App <223556219+Copilot@users.noreply.github.com>
</commit_message>
<xml_diff>
--- a/.github/extensions/markdstage/test/fixtures/pptx-editable.golden.pptx
+++ b/.github/extensions/markdstage/test/fixtures/pptx-editable.golden.pptx
@@ -17,89 +17,7 @@
 </p:presentation>
 </file>
 
-<file path=ppt/notesMasters/notesMaster1.xml><?xml version="1.0" encoding="utf-8"?>
-<p:notesMaster xmlns:a="http://schemas.openxmlformats.org/drawingml/2006/main" xmlns:r="http://schemas.openxmlformats.org/officeDocument/2006/relationships" xmlns:p="http://schemas.openxmlformats.org/presentationml/2006/main">
-  <p:cSld name="Notes Master">
-    <p:spTree>
-      <p:nvGrpSpPr>
-        <p:cNvPr id="1" name=""/>
-        <p:cNvGrpSpPr/>
-        <p:nvPr/>
-      </p:nvGrpSpPr>
-      <p:grpSpPr>
-        <a:xfrm>
-          <a:off x="0" y="0"/>
-          <a:ext cx="0" cy="0"/>
-          <a:chOff x="0" y="0"/>
-          <a:chExt cx="0" cy="0"/>
-        </a:xfrm>
-      </p:grpSpPr>
-      <p:sp>
-        <p:nvSpPr>
-          <p:cNvPr id="2" name="Slide Image Placeholder 1"/>
-          <p:cNvSpPr txBox="1"/>
-          <p:nvPr>
-            <p:ph type="sldImg" idx="1"/>
-          </p:nvPr>
-        </p:nvSpPr>
-        <p:spPr>
-          <a:xfrm>
-            <a:off x="1143000" y="685800"/>
-            <a:ext cx="4572000" cy="3429000"/>
-          </a:xfrm>
-          <a:prstGeom prst="rect">
-            <a:avLst/>
-          </a:prstGeom>
-          <a:noFill/>
-          <a:ln>
-            <a:noFill/>
-          </a:ln>
-        </p:spPr>
-        <p:txBody>
-          <a:bodyPr/>
-          <a:lstStyle/>
-          <a:p/>
-        </p:txBody>
-      </p:sp>
-      <p:sp>
-        <p:nvSpPr>
-          <p:cNvPr id="3" name="Notes Placeholder 2"/>
-          <p:cNvSpPr txBox="1"/>
-          <p:nvPr>
-            <p:ph type="body" idx="2"/>
-          </p:nvPr>
-        </p:nvSpPr>
-        <p:spPr>
-          <a:xfrm>
-            <a:off x="685800" y="4343400"/>
-            <a:ext cx="5486400" cy="4114800"/>
-          </a:xfrm>
-          <a:prstGeom prst="rect">
-            <a:avLst/>
-          </a:prstGeom>
-          <a:noFill/>
-          <a:ln>
-            <a:noFill/>
-          </a:ln>
-        </p:spPr>
-        <p:txBody>
-          <a:bodyPr/>
-          <a:lstStyle/>
-          <a:p/>
-        </p:txBody>
-      </p:sp>
-    </p:spTree>
-  </p:cSld>
-  <p:clrMap accent1="accent1" accent2="accent2" accent3="accent3" accent4="accent4" accent5="accent5" accent6="accent6" bg1="lt1" bg2="lt2" folHlink="folHlink" hlink="hlink" tx1="dk1" tx2="dk2"/>
-  <p:notesStyle>
-    <a:lvl1pPr marL="0" algn="l">
-      <a:defRPr sz="1200">
-        <a:latin typeface="Aptos"/>
-        <a:ea typeface="Yu Gothic"/>
-      </a:defRPr>
-    </a:lvl1pPr>
-  </p:notesStyle>
-</p:notesMaster>
+<file path=ppt/notesMasters/notesMaster1.xml><?xml version="1.0" encoding="UTF-8" standalone="yes"?><p:notesMaster xmlns:a="http://schemas.openxmlformats.org/drawingml/2006/main" xmlns:r="http://schemas.openxmlformats.org/officeDocument/2006/relationships" xmlns:p="http://schemas.openxmlformats.org/presentationml/2006/main"><p:cSld name="Notes Master"><p:spTree><p:nvGrpSpPr><p:cNvPr id="1" name=""/><p:cNvGrpSpPr/><p:nvPr/></p:nvGrpSpPr><p:grpSpPr><a:xfrm><a:off x="0" y="0"/><a:ext cx="0" cy="0"/><a:chOff x="0" y="0"/><a:chExt cx="0" cy="0"/></a:xfrm></p:grpSpPr><p:sp><p:nvSpPr><p:cNvPr id="2" name="Slide Image Placeholder 1"/><p:cNvSpPr txBox="1"/><p:nvPr><p:ph type="sldImg" idx="1"/></p:nvPr></p:nvSpPr><p:spPr><a:xfrm><a:off x="1143000" y="685800"/><a:ext cx="4572000" cy="3429000"/></a:xfrm><a:prstGeom prst="rect"><a:avLst/></a:prstGeom><a:noFill/><a:ln><a:noFill/></a:ln></p:spPr><p:txBody><a:bodyPr/><a:lstStyle/><a:p/></p:txBody></p:sp><p:sp><p:nvSpPr><p:cNvPr id="3" name="Notes Placeholder 2"/><p:cNvSpPr txBox="1"/><p:nvPr><p:ph type="body" idx="2"/></p:nvPr></p:nvSpPr><p:spPr><a:xfrm><a:off x="685800" y="4343400"/><a:ext cx="5486400" cy="4114800"/></a:xfrm><a:prstGeom prst="rect"><a:avLst/></a:prstGeom><a:noFill/><a:ln><a:noFill/></a:ln></p:spPr><p:txBody><a:bodyPr/><a:lstStyle/><a:p/></p:txBody></p:sp></p:spTree></p:cSld><p:clrMap accent1="accent1" accent2="accent2" accent3="accent3" accent4="accent4" accent5="accent5" accent6="accent6" bg1="lt1" bg2="lt2" folHlink="folHlink" hlink="hlink" tx1="dk1" tx2="dk2"/><p:notesStyle><a:lvl1pPr marL="0" algn="l"><a:defRPr sz="1200"><a:latin typeface="Segoe UI"/><a:ea typeface="Yu Gothic UI"/></a:defRPr></a:lvl1pPr></p:notesMaster>
 </file>
 
 <file path=ppt/notesSlides/notesSlide1.xml><?xml version="1.0" encoding="utf-8"?>
@@ -173,28 +91,28 @@
           <a:p>
             <a:r>
               <a:rPr lang="en-US" dirty="0">
-                <a:ea typeface="Yu Gothic"/>
+                <a:ea typeface="Yu Gothic UI"/>
               </a:rPr>
               <a:t>発表者ノート &amp; &lt;詳細&gt;.</a:t>
             </a:r>
             <a:endParaRPr lang="en-US">
-              <a:ea typeface="Yu Gothic"/>
+              <a:ea typeface="Yu Gothic UI"/>
             </a:endParaRPr>
           </a:p>
           <a:p>
             <a:endParaRPr lang="en-US">
-              <a:ea typeface="Yu Gothic"/>
+              <a:ea typeface="Yu Gothic UI"/>
             </a:endParaRPr>
           </a:p>
           <a:p>
             <a:r>
               <a:rPr lang="en-US" dirty="0">
-                <a:ea typeface="Yu Gothic"/>
+                <a:ea typeface="Yu Gothic UI"/>
               </a:rPr>
               <a:t xml:space="preserve">  Кириллица — العربية 🧪</a:t>
             </a:r>
             <a:endParaRPr lang="en-US">
-              <a:ea typeface="Yu Gothic"/>
+              <a:ea typeface="Yu Gothic UI"/>
             </a:endParaRPr>
           </a:p>
         </p:txBody>
@@ -336,13 +254,13 @@
                   <a:srgbClr val="0C2238"/>
                 </a:solidFill>
                 <a:latin typeface="Yu Gothic"/>
-                <a:ea typeface="Yu Gothic"/>
+                <a:ea typeface="Yu Gothic UI"/>
                 <a:hlinkClick r:id="rId3"/>
               </a:rPr>
               <a:t>日本語 &amp; &lt;編集&gt; — Ελληνικά 🚀</a:t>
             </a:r>
             <a:endParaRPr lang="en-US" noProof="1">
-              <a:ea typeface="Yu Gothic"/>
+              <a:ea typeface="Yu Gothic UI"/>
             </a:endParaRPr>
           </a:p>
         </p:txBody>
@@ -377,12 +295,12 @@
                           <a:solidFill>
                             <a:srgbClr val="000000"/>
                           </a:solidFill>
-                          <a:ea typeface="Yu Gothic"/>
+                          <a:ea typeface="Yu Gothic UI"/>
                         </a:rPr>
                         <a:t>項目</a:t>
                       </a:r>
                       <a:endParaRPr lang="en-US" noProof="1">
-                        <a:ea typeface="Yu Gothic"/>
+                        <a:ea typeface="Yu Gothic UI"/>
                       </a:endParaRPr>
                     </a:p>
                   </a:txBody>
@@ -423,12 +341,12 @@
                           <a:solidFill>
                             <a:srgbClr val="000000"/>
                           </a:solidFill>
-                          <a:ea typeface="Yu Gothic"/>
+                          <a:ea typeface="Yu Gothic UI"/>
                         </a:rPr>
                         <a:t>値</a:t>
                       </a:r>
                       <a:endParaRPr lang="en-US" noProof="1">
-                        <a:ea typeface="Yu Gothic"/>
+                        <a:ea typeface="Yu Gothic UI"/>
                       </a:endParaRPr>
                     </a:p>
                   </a:txBody>
@@ -469,12 +387,12 @@
                           <a:solidFill>
                             <a:srgbClr val="000000"/>
                           </a:solidFill>
-                          <a:ea typeface="Yu Gothic"/>
+                          <a:ea typeface="Yu Gothic UI"/>
                         </a:rPr>
                         <a:t>Δ</a:t>
                       </a:r>
                       <a:endParaRPr lang="en-US" noProof="1">
-                        <a:ea typeface="Yu Gothic"/>
+                        <a:ea typeface="Yu Gothic UI"/>
                       </a:endParaRPr>
                     </a:p>
                   </a:txBody>
@@ -515,12 +433,12 @@
                           <a:solidFill>
                             <a:srgbClr val="000000"/>
                           </a:solidFill>
-                          <a:ea typeface="Yu Gothic"/>
+                          <a:ea typeface="Yu Gothic UI"/>
                         </a:rPr>
                         <a:t>42 &amp; &lt;43&gt;</a:t>
                       </a:r>
                       <a:endParaRPr lang="en-US" noProof="1">
-                        <a:ea typeface="Yu Gothic"/>
+                        <a:ea typeface="Yu Gothic UI"/>
                       </a:endParaRPr>
                     </a:p>
                   </a:txBody>
@@ -616,12 +534,12 @@
                 <a:solidFill>
                   <a:srgbClr val="000000"/>
                 </a:solidFill>
-                <a:ea typeface="Yu Gothic"/>
+                <a:ea typeface="Yu Gothic UI"/>
               </a:rPr>
               <a:t>編集可能</a:t>
             </a:r>
             <a:endParaRPr lang="en-US" noProof="1">
-              <a:ea typeface="Yu Gothic"/>
+              <a:ea typeface="Yu Gothic UI"/>
             </a:endParaRPr>
           </a:p>
         </p:txBody>
@@ -700,12 +618,12 @@
                 <a:solidFill>
                   <a:srgbClr val="000000"/>
                 </a:solidFill>
-                <a:ea typeface="Yu Gothic"/>
+                <a:ea typeface="Yu Gothic UI"/>
               </a:rPr>
               <a:t>流れ</a:t>
             </a:r>
             <a:endParaRPr lang="en-US" noProof="1">
-              <a:ea typeface="Yu Gothic"/>
+              <a:ea typeface="Yu Gothic UI"/>
             </a:endParaRPr>
           </a:p>
         </p:txBody>
@@ -786,16 +704,16 @@
     </a:clrScheme>
     <a:fontScheme name="MarkdStage dark">
       <a:majorFont>
-        <a:latin typeface="Aptos Display"/>
-        <a:ea typeface="Yu Gothic"/>
+        <a:latin typeface="Segoe UI"/>
+        <a:ea typeface="Yu Gothic UI"/>
         <a:cs typeface=""/>
-        <a:font script="Jpan" typeface="Yu Gothic"/>
+        <a:font script="Jpan" typeface="Yu Gothic UI"/>
       </a:majorFont>
       <a:minorFont>
-        <a:latin typeface="Aptos"/>
-        <a:ea typeface="Yu Gothic"/>
+        <a:latin typeface="Segoe UI"/>
+        <a:ea typeface="Yu Gothic UI"/>
         <a:cs typeface=""/>
-        <a:font script="Jpan" typeface="Yu Gothic"/>
+        <a:font script="Jpan" typeface="Yu Gothic UI"/>
       </a:minorFont>
     </a:fontScheme>
     <a:fmtScheme name="MarkdStage dark">
@@ -897,16 +815,16 @@
     </a:clrScheme>
     <a:fontScheme name="MarkdStage Notes">
       <a:majorFont>
-        <a:latin typeface="Aptos Display"/>
-        <a:ea typeface="Yu Gothic"/>
+        <a:latin typeface="Segoe UI"/>
+        <a:ea typeface="Yu Gothic UI"/>
         <a:cs typeface=""/>
-        <a:font script="Jpan" typeface="Yu Gothic"/>
+        <a:font script="Jpan" typeface="Yu Gothic UI"/>
       </a:majorFont>
       <a:minorFont>
-        <a:latin typeface="Aptos"/>
-        <a:ea typeface="Yu Gothic"/>
+        <a:latin typeface="Segoe UI"/>
+        <a:ea typeface="Yu Gothic UI"/>
         <a:cs typeface=""/>
-        <a:font script="Jpan" typeface="Yu Gothic"/>
+        <a:font script="Jpan" typeface="Yu Gothic UI"/>
       </a:minorFont>
     </a:fontScheme>
     <a:fmtScheme name="MarkdStage Notes">

</xml_diff>

<commit_message>
Fix PPTX golden fixtures for notes XML corruption
Co-authored-by: Copilot App <223556219+Copilot@users.noreply.github.com>
Copilot-Session: 61fae30c-7772-4d96-a496-79ae51fe87c4
</commit_message>
<xml_diff>
--- a/.github/extensions/markdstage/test/fixtures/pptx-editable.golden.pptx
+++ b/.github/extensions/markdstage/test/fixtures/pptx-editable.golden.pptx
@@ -17,7 +17,89 @@
 </p:presentation>
 </file>
 
-<file path=ppt/notesMasters/notesMaster1.xml><?xml version="1.0" encoding="UTF-8" standalone="yes"?><p:notesMaster xmlns:a="http://schemas.openxmlformats.org/drawingml/2006/main" xmlns:r="http://schemas.openxmlformats.org/officeDocument/2006/relationships" xmlns:p="http://schemas.openxmlformats.org/presentationml/2006/main"><p:cSld name="Notes Master"><p:spTree><p:nvGrpSpPr><p:cNvPr id="1" name=""/><p:cNvGrpSpPr/><p:nvPr/></p:nvGrpSpPr><p:grpSpPr><a:xfrm><a:off x="0" y="0"/><a:ext cx="0" cy="0"/><a:chOff x="0" y="0"/><a:chExt cx="0" cy="0"/></a:xfrm></p:grpSpPr><p:sp><p:nvSpPr><p:cNvPr id="2" name="Slide Image Placeholder 1"/><p:cNvSpPr txBox="1"/><p:nvPr><p:ph type="sldImg" idx="1"/></p:nvPr></p:nvSpPr><p:spPr><a:xfrm><a:off x="1143000" y="685800"/><a:ext cx="4572000" cy="3429000"/></a:xfrm><a:prstGeom prst="rect"><a:avLst/></a:prstGeom><a:noFill/><a:ln><a:noFill/></a:ln></p:spPr><p:txBody><a:bodyPr/><a:lstStyle/><a:p/></p:txBody></p:sp><p:sp><p:nvSpPr><p:cNvPr id="3" name="Notes Placeholder 2"/><p:cNvSpPr txBox="1"/><p:nvPr><p:ph type="body" idx="2"/></p:nvPr></p:nvSpPr><p:spPr><a:xfrm><a:off x="685800" y="4343400"/><a:ext cx="5486400" cy="4114800"/></a:xfrm><a:prstGeom prst="rect"><a:avLst/></a:prstGeom><a:noFill/><a:ln><a:noFill/></a:ln></p:spPr><p:txBody><a:bodyPr/><a:lstStyle/><a:p/></p:txBody></p:sp></p:spTree></p:cSld><p:clrMap accent1="accent1" accent2="accent2" accent3="accent3" accent4="accent4" accent5="accent5" accent6="accent6" bg1="lt1" bg2="lt2" folHlink="folHlink" hlink="hlink" tx1="dk1" tx2="dk2"/><p:notesStyle><a:lvl1pPr marL="0" algn="l"><a:defRPr sz="1200"><a:latin typeface="Segoe UI"/><a:ea typeface="Yu Gothic UI"/></a:defRPr></a:lvl1pPr></p:notesMaster>
+<file path=ppt/notesMasters/notesMaster1.xml><?xml version="1.0" encoding="utf-8"?>
+<p:notesMaster xmlns:a="http://schemas.openxmlformats.org/drawingml/2006/main" xmlns:r="http://schemas.openxmlformats.org/officeDocument/2006/relationships" xmlns:p="http://schemas.openxmlformats.org/presentationml/2006/main">
+  <p:cSld name="Notes Master">
+    <p:spTree>
+      <p:nvGrpSpPr>
+        <p:cNvPr id="1" name=""/>
+        <p:cNvGrpSpPr/>
+        <p:nvPr/>
+      </p:nvGrpSpPr>
+      <p:grpSpPr>
+        <a:xfrm>
+          <a:off x="0" y="0"/>
+          <a:ext cx="0" cy="0"/>
+          <a:chOff x="0" y="0"/>
+          <a:chExt cx="0" cy="0"/>
+        </a:xfrm>
+      </p:grpSpPr>
+      <p:sp>
+        <p:nvSpPr>
+          <p:cNvPr id="2" name="Slide Image Placeholder 1"/>
+          <p:cNvSpPr txBox="1"/>
+          <p:nvPr>
+            <p:ph type="sldImg" idx="1"/>
+          </p:nvPr>
+        </p:nvSpPr>
+        <p:spPr>
+          <a:xfrm>
+            <a:off x="1143000" y="685800"/>
+            <a:ext cx="4572000" cy="3429000"/>
+          </a:xfrm>
+          <a:prstGeom prst="rect">
+            <a:avLst/>
+          </a:prstGeom>
+          <a:noFill/>
+          <a:ln>
+            <a:noFill/>
+          </a:ln>
+        </p:spPr>
+        <p:txBody>
+          <a:bodyPr/>
+          <a:lstStyle/>
+          <a:p/>
+        </p:txBody>
+      </p:sp>
+      <p:sp>
+        <p:nvSpPr>
+          <p:cNvPr id="3" name="Notes Placeholder 2"/>
+          <p:cNvSpPr txBox="1"/>
+          <p:nvPr>
+            <p:ph type="body" idx="2"/>
+          </p:nvPr>
+        </p:nvSpPr>
+        <p:spPr>
+          <a:xfrm>
+            <a:off x="685800" y="4343400"/>
+            <a:ext cx="5486400" cy="4114800"/>
+          </a:xfrm>
+          <a:prstGeom prst="rect">
+            <a:avLst/>
+          </a:prstGeom>
+          <a:noFill/>
+          <a:ln>
+            <a:noFill/>
+          </a:ln>
+        </p:spPr>
+        <p:txBody>
+          <a:bodyPr/>
+          <a:lstStyle/>
+          <a:p/>
+        </p:txBody>
+      </p:sp>
+    </p:spTree>
+  </p:cSld>
+  <p:clrMap accent1="accent1" accent2="accent2" accent3="accent3" accent4="accent4" accent5="accent5" accent6="accent6" bg1="lt1" bg2="lt2" folHlink="folHlink" hlink="hlink" tx1="dk1" tx2="dk2"/>
+  <p:notesStyle>
+    <a:lvl1pPr marL="0" algn="l">
+      <a:defRPr sz="1200">
+        <a:latin typeface="Segoe UI"/>
+        <a:ea typeface="Yu Gothic UI"/>
+      </a:defRPr>
+    </a:lvl1pPr>
+  </p:notesStyle>
+</p:notesMaster>
 </file>
 
 <file path=ppt/notesSlides/notesSlide1.xml><?xml version="1.0" encoding="utf-8"?>

</xml_diff>

<commit_message>
Fix PPTX notes master XML corruption (#213)
* Fix PPTX notes master XML corruption

Restores the missing closing tag in the notes master XML so exported PPTX files with speaker notes stay readable in PowerPoint.

Fixes: #212

Co-authored-by: Copilot App <223556219+Copilot@users.noreply.github.com>
Copilot-Session: 61fae30c-7772-4d96-a496-79ae51fe87c4

* Fix PPTX golden fixtures for notes XML corruption

Co-authored-by: Copilot App <223556219+Copilot@users.noreply.github.com>
Copilot-Session: 61fae30c-7772-4d96-a496-79ae51fe87c4

---------

Co-authored-by: Kazuki Ota <117221407+kaota_microsoft@users.noreply.github.com>
Co-authored-by: Copilot App <223556219+Copilot@users.noreply.github.com>
Copilot-Session: 61fae30c-7772-4d96-a496-79ae51fe87c4
</commit_message>
<xml_diff>
--- a/.github/extensions/markdstage/test/fixtures/pptx-editable.golden.pptx
+++ b/.github/extensions/markdstage/test/fixtures/pptx-editable.golden.pptx
@@ -17,7 +17,89 @@
 </p:presentation>
 </file>
 
-<file path=ppt/notesMasters/notesMaster1.xml><?xml version="1.0" encoding="UTF-8" standalone="yes"?><p:notesMaster xmlns:a="http://schemas.openxmlformats.org/drawingml/2006/main" xmlns:r="http://schemas.openxmlformats.org/officeDocument/2006/relationships" xmlns:p="http://schemas.openxmlformats.org/presentationml/2006/main"><p:cSld name="Notes Master"><p:spTree><p:nvGrpSpPr><p:cNvPr id="1" name=""/><p:cNvGrpSpPr/><p:nvPr/></p:nvGrpSpPr><p:grpSpPr><a:xfrm><a:off x="0" y="0"/><a:ext cx="0" cy="0"/><a:chOff x="0" y="0"/><a:chExt cx="0" cy="0"/></a:xfrm></p:grpSpPr><p:sp><p:nvSpPr><p:cNvPr id="2" name="Slide Image Placeholder 1"/><p:cNvSpPr txBox="1"/><p:nvPr><p:ph type="sldImg" idx="1"/></p:nvPr></p:nvSpPr><p:spPr><a:xfrm><a:off x="1143000" y="685800"/><a:ext cx="4572000" cy="3429000"/></a:xfrm><a:prstGeom prst="rect"><a:avLst/></a:prstGeom><a:noFill/><a:ln><a:noFill/></a:ln></p:spPr><p:txBody><a:bodyPr/><a:lstStyle/><a:p/></p:txBody></p:sp><p:sp><p:nvSpPr><p:cNvPr id="3" name="Notes Placeholder 2"/><p:cNvSpPr txBox="1"/><p:nvPr><p:ph type="body" idx="2"/></p:nvPr></p:nvSpPr><p:spPr><a:xfrm><a:off x="685800" y="4343400"/><a:ext cx="5486400" cy="4114800"/></a:xfrm><a:prstGeom prst="rect"><a:avLst/></a:prstGeom><a:noFill/><a:ln><a:noFill/></a:ln></p:spPr><p:txBody><a:bodyPr/><a:lstStyle/><a:p/></p:txBody></p:sp></p:spTree></p:cSld><p:clrMap accent1="accent1" accent2="accent2" accent3="accent3" accent4="accent4" accent5="accent5" accent6="accent6" bg1="lt1" bg2="lt2" folHlink="folHlink" hlink="hlink" tx1="dk1" tx2="dk2"/><p:notesStyle><a:lvl1pPr marL="0" algn="l"><a:defRPr sz="1200"><a:latin typeface="Segoe UI"/><a:ea typeface="Yu Gothic UI"/></a:defRPr></a:lvl1pPr></p:notesMaster>
+<file path=ppt/notesMasters/notesMaster1.xml><?xml version="1.0" encoding="utf-8"?>
+<p:notesMaster xmlns:a="http://schemas.openxmlformats.org/drawingml/2006/main" xmlns:r="http://schemas.openxmlformats.org/officeDocument/2006/relationships" xmlns:p="http://schemas.openxmlformats.org/presentationml/2006/main">
+  <p:cSld name="Notes Master">
+    <p:spTree>
+      <p:nvGrpSpPr>
+        <p:cNvPr id="1" name=""/>
+        <p:cNvGrpSpPr/>
+        <p:nvPr/>
+      </p:nvGrpSpPr>
+      <p:grpSpPr>
+        <a:xfrm>
+          <a:off x="0" y="0"/>
+          <a:ext cx="0" cy="0"/>
+          <a:chOff x="0" y="0"/>
+          <a:chExt cx="0" cy="0"/>
+        </a:xfrm>
+      </p:grpSpPr>
+      <p:sp>
+        <p:nvSpPr>
+          <p:cNvPr id="2" name="Slide Image Placeholder 1"/>
+          <p:cNvSpPr txBox="1"/>
+          <p:nvPr>
+            <p:ph type="sldImg" idx="1"/>
+          </p:nvPr>
+        </p:nvSpPr>
+        <p:spPr>
+          <a:xfrm>
+            <a:off x="1143000" y="685800"/>
+            <a:ext cx="4572000" cy="3429000"/>
+          </a:xfrm>
+          <a:prstGeom prst="rect">
+            <a:avLst/>
+          </a:prstGeom>
+          <a:noFill/>
+          <a:ln>
+            <a:noFill/>
+          </a:ln>
+        </p:spPr>
+        <p:txBody>
+          <a:bodyPr/>
+          <a:lstStyle/>
+          <a:p/>
+        </p:txBody>
+      </p:sp>
+      <p:sp>
+        <p:nvSpPr>
+          <p:cNvPr id="3" name="Notes Placeholder 2"/>
+          <p:cNvSpPr txBox="1"/>
+          <p:nvPr>
+            <p:ph type="body" idx="2"/>
+          </p:nvPr>
+        </p:nvSpPr>
+        <p:spPr>
+          <a:xfrm>
+            <a:off x="685800" y="4343400"/>
+            <a:ext cx="5486400" cy="4114800"/>
+          </a:xfrm>
+          <a:prstGeom prst="rect">
+            <a:avLst/>
+          </a:prstGeom>
+          <a:noFill/>
+          <a:ln>
+            <a:noFill/>
+          </a:ln>
+        </p:spPr>
+        <p:txBody>
+          <a:bodyPr/>
+          <a:lstStyle/>
+          <a:p/>
+        </p:txBody>
+      </p:sp>
+    </p:spTree>
+  </p:cSld>
+  <p:clrMap accent1="accent1" accent2="accent2" accent3="accent3" accent4="accent4" accent5="accent5" accent6="accent6" bg1="lt1" bg2="lt2" folHlink="folHlink" hlink="hlink" tx1="dk1" tx2="dk2"/>
+  <p:notesStyle>
+    <a:lvl1pPr marL="0" algn="l">
+      <a:defRPr sz="1200">
+        <a:latin typeface="Segoe UI"/>
+        <a:ea typeface="Yu Gothic UI"/>
+      </a:defRPr>
+    </a:lvl1pPr>
+  </p:notesStyle>
+</p:notesMaster>
 </file>
 
 <file path=ppt/notesSlides/notesSlide1.xml><?xml version="1.0" encoding="utf-8"?>

</xml_diff>